<commit_message>
docs: rework the pitch deck after mentor feedback
The deck now pitches one user, one payer and one moment: digital
workers at HRD Corp levy-paying employers, when AI coding tools arrive.
It adds a Who Pays slide and course platforms on the innovation slide,
fixes the Claude model and repo link, and closes with QR codes.

Claude-Session: https://claude.ai/code/session_01Y1E5CjXFy5chzyKGoiB3jf
</commit_message>
<xml_diff>
--- a/docs/demo/deck/kotak-pitch-deck.pptx
+++ b/docs/demo/deck/kotak-pitch-deck.pptx
@@ -16,6 +16,7 @@
     <p:sldId id="264" r:id="rId16"/>
     <p:sldId id="265" r:id="rId17"/>
     <p:sldId id="266" r:id="rId18"/>
+    <p:sldId id="267" r:id="rId19"/>
   </p:sldIdLst>
   <p:sldSz cx="12191695" cy="6858000" type="screen4x3"/>
   <p:notesSz cx="6858000" cy="9144000"/>
@@ -512,7 +513,7 @@
           <a:lstStyle/>
           <a:p>
             <a:r>
-              <a:t>Kotak, Team T010NG, Domain 1. One line: every Malaysian worker can see what AI does to their job and what to learn next. Five builders; I am Hee Zi Jie, product lead. The live build is on Replit.</a:t>
+              <a:t>Kotak is for software and digital workers in Malaysia. We focus on developers, testers and designers at employers that pay the HRD Corp levy. They get a plan for what to learn next. We are Team T010NG. The build is live on Replit.</a:t>
             </a:r>
           </a:p>
         </p:txBody>
@@ -582,7 +583,7 @@
           <a:lstStyle/>
           <a:p>
             <a:r>
-              <a:t>One Cloudflare Worker serves the app and API. The browser recomputes verdicts from committed snapshots; no model call in the loop. Neon holds the anonymous national view with a k of 10. Claude explains, ElevenLabs speaks, RunPod built the batch, Replit is the sponsor proof. If Claude is overloaded, cached answers or a fixed template; the verdict never changes.</a:t>
+              <a:t>Workers use Kotak free. Employers are the payer. Next, they pay Kotak for a team view that helps them decide where to spend their training levy. That view is not built yet. The levy is separate from payment for Kotak. Registered employers pay one percent of wages plus fixed allowances each month, or half a percent in the optional category. They apply before training and claim approved costs. The HRD Corp FAQ is the source. Agencies get the built anonymous national view, for groups of ten or more. An employer's own HR assistant can call the same rules through MCP. Grants are a route to explore.</a:t>
             </a:r>
           </a:p>
         </p:txBody>
@@ -652,7 +653,77 @@
           <a:lstStyle/>
           <a:p>
             <a:r>
-              <a:t>We want the hardest question, not a compliment. Who buys first, which proof is credible, and what would make you not fund this. The live demo and source code are on the QR cards.</a:t>
+              <a:t>The browser runs the rules over committed snapshots. A Cloudflare Worker serves the app and API. Neon stores anonymous national totals. Claude Haiku 5.5 explains the results; this matches the code. Live2D animates Kopi. ElevenLabs supplies cached voice. RunPod supports the batch build. Replit hosts the live demo. Cached answers and fixed text keep the verdict unchanged when Claude fails.</a:t>
+            </a:r>
+          </a:p>
+        </p:txBody>
+      </p:sp>
+      <p:sp>
+        <p:nvSpPr>
+          <p:cNvPr id="4" name="Slide Number Placeholder 3"/>
+          <p:cNvSpPr>
+            <a:spLocks noGrp="1"/>
+          </p:cNvSpPr>
+          <p:nvPr>
+            <p:ph type="sldNum" idx="5" sz="quarter"/>
+          </p:nvPr>
+        </p:nvSpPr>
+        <p:spPr/>
+      </p:sp>
+    </p:spTree>
+  </p:cSld>
+  <p:clrMapOvr>
+    <a:masterClrMapping/>
+  </p:clrMapOvr>
+</p:notes>
+</file>
+
+<file path=ppt/notesSlides/notesSlide12.xml><?xml version="1.0" encoding="utf-8"?>
+<p:notes xmlns:a="http://schemas.openxmlformats.org/drawingml/2006/main" xmlns:p="http://schemas.openxmlformats.org/presentationml/2006/main" xmlns:r="http://schemas.openxmlformats.org/officeDocument/2006/relationships">
+  <p:cSld>
+    <p:spTree>
+      <p:nvGrpSpPr>
+        <p:cNvPr id="1" name=""/>
+        <p:cNvGrpSpPr/>
+        <p:nvPr/>
+      </p:nvGrpSpPr>
+      <p:grpSpPr>
+        <a:xfrm>
+          <a:off x="0" y="0"/>
+          <a:ext cx="0" cy="0"/>
+          <a:chOff x="0" y="0"/>
+          <a:chExt cx="0" cy="0"/>
+        </a:xfrm>
+      </p:grpSpPr>
+      <p:sp>
+        <p:nvSpPr>
+          <p:cNvPr id="2" name="Slide Image Placeholder 1"/>
+          <p:cNvSpPr>
+            <a:spLocks noGrp="1"/>
+          </p:cNvSpPr>
+          <p:nvPr>
+            <p:ph type="sldImg" idx="2"/>
+          </p:nvPr>
+        </p:nvSpPr>
+        <p:spPr/>
+      </p:sp>
+      <p:sp>
+        <p:nvSpPr>
+          <p:cNvPr id="3" name="Notes Placeholder 2"/>
+          <p:cNvSpPr>
+            <a:spLocks noGrp="1"/>
+          </p:cNvSpPr>
+          <p:nvPr>
+            <p:ph type="body" idx="3" sz="quarter"/>
+          </p:nvPr>
+        </p:nvSpPr>
+        <p:spPr/>
+        <p:txBody>
+          <a:bodyPr/>
+          <a:lstStyle/>
+          <a:p>
+            <a:r>
+              <a:t>Try the live demo with the sample profile. The demo QR opens the app. The code QR opens the Kotak repository. Connect Your AI is at slash app slash connect. Copy the MCP setup there. Your assistant calls the same rules as the web app. Data decides. AI explains.</a:t>
             </a:r>
           </a:p>
         </p:txBody>
@@ -722,7 +793,7 @@
           <a:lstStyle/>
           <a:p>
             <a:r>
-              <a:t>The 56 and 26 are Hays Asia Salary Guide 2025 via the Domain 1 brief. 620,000 and 18% are TalentCorp's Impact Study. 28% is World Bank and ISIS Malaysia. Three different scopes, each labelled. The gap is not awareness; it is a dated next step.</a:t>
+              <a:t>These are national figures, not figures for software workers alone. Hays reports 56 percent use AI and 26 percent have formal training. TalentCorp projects 620,000 workers affected in the sectors studied. World Bank and ISIS Malaysia report 28 percent highly exposed. Our moment is a manager deciding what training to fund as AI coding tools arrive.</a:t>
             </a:r>
           </a:p>
         </p:txBody>
@@ -792,7 +863,7 @@
           <a:lstStyle/>
           <a:p>
             <a:r>
-              <a:t>Our user is a working adult in any industry, with a worry and a few minutes, usually on a phone. Three modes: stay strong, move to a target role, or find where to go. The second reader is TalentCorp or HRD Corp.</a:t>
+              <a:t>Aina is a sample persona. We invented her for this pitch. She is a front-end developer in Kuala Lumpur. Her employer pays the HRD Corp levy. The company rolls out AI coding tools. Her manager asks what training to fund this year. She needs a plan she can show him. The engine covers 923 jobs. Our first group is software and digital workers.</a:t>
             </a:r>
           </a:p>
         </p:txBody>
@@ -862,7 +933,7 @@
           <a:lstStyle/>
           <a:p>
             <a:r>
-              <a:t>Twelve yes or no can-do questions. Six skills built from the job's own tasks. Three ranked roles. A 12-week plan of free steps with a finish date. About three minutes. All six must-haves are on this loop.</a:t>
+              <a:t>Aina leaves with a dated plan. This sample starts on 2 November 2026 and ends on 24 January 2027. Code review takes three hours a week. Accessibility and practice take four. The fast scenario adds two hours for testing. GitHub Skills, W3C WAI, MDN and freeCodeCamp are free. Other roles show unchecked search suggestions. The funding card tells a levy-paying employer to apply before training and claim only approved costs. The screenshot is the existing sample build. These cost and funding labels are part of the sample-plan update.</a:t>
             </a:r>
           </a:p>
         </p:txBody>
@@ -932,7 +1003,7 @@
           <a:lstStyle/>
           <a:p>
             <a:r>
-              <a:t>This is the core. Snapshots are dated. Rules set every verdict, score and order in the browser. AI does three jobs: drafts questions offline, explains from cited rows, and voices Kopi. It never sets a verdict. Split and Unknown are valid answers.</a:t>
+              <a:t>Dated snapshots feed fixed rules. The browser sets verdicts, scores and plan order. RunPod drafts skills and questions offline. Claude explains the cited rows. Kopi reads its lines aloud. Text and mute stay available. AI never sets a verdict. If it fails, a fixed template answers. Split and Unknown are valid results.</a:t>
             </a:r>
           </a:p>
         </p:txBody>
@@ -1002,7 +1073,7 @@
           <a:lstStyle/>
           <a:p>
             <a:r>
-              <a:t>This is the live demo moment. Same profile, same rules, only the snapshot changes from April to May 2026. Testing moves Split to Rising; Design Systems moves Steady to Rising; Design Systems Developer becomes the top match at 74%; the roadmap pulls in a testing milestone.</a:t>
+              <a:t>This is the sample-data demo. Keep the same profile and answers. Change April to May. Testing moves from Split to Rising. Design Systems moves from Steady to Rising. The sample top match is Design Systems Developer at 74 percent. The roadmap adds testing. The sample shows how a new snapshot changes the plan.</a:t>
             </a:r>
           </a:p>
         </p:txBody>
@@ -1072,7 +1143,7 @@
           <a:lstStyle/>
           <a:p>
             <a:r>
-              <a:t>Five of the 13 views, phone and desktop. Every screen carries the Sample Data label. The build is live on Replit; the Cloudflare Worker is the production path.</a:t>
+              <a:t>These are existing screens from the live prototype. The check-up, radar, roles and roadmap form the worker's loop. The national view is built too. It hides groups smaller than ten. The app has phone and desktop layouts. The screenshots carry the Sample Data label.</a:t>
             </a:r>
           </a:p>
         </p:txBody>
@@ -1142,7 +1213,7 @@
           <a:lstStyle/>
           <a:p>
             <a:r>
-              <a:t>MyMahir maps roles and skills but has no score, time, scenario or SDG tag. LinkedIn scores similarity but no trend or plan. The closest winners explain a score; neither shows more than one future or Malaysian data. Our claim is the mechanism: dated signal, fixed rules, timed plan, public view.</a:t>
+              <a:t>MyMahir maps roles and skills. LinkedIn compares skills across roles. MasterClass offers expert video courses by subscription. ReSkills is a Malaysian subscription platform for live online classes. Its provider claim is attributed to NST in 2021. e-LATiH offers free and premium courses. They offer courses. Kotak tells you which skill to learn first and why now, then points you to them. The dated rules and timed plan are our contribution.</a:t>
             </a:r>
           </a:p>
         </p:txBody>
@@ -1212,7 +1283,7 @@
           <a:lstStyle/>
           <a:p>
             <a:r>
-              <a:t>Target 4.4 is the official text. Baseline is 39.8% with above-basic digital skills in all five areas and 19.6% who wrote code, from DOSM via the UN SDG API. Our KPI is the sourced-roadmap rate: 100% of 20 seeded profiles in under three minutes with zero uncited recommendations. We do not claim lives saved or jobs placed.</a:t>
+              <a:t>SDG target 4.4 concerns skills for work. DOSM provides the Malaysia baseline through the UN SDG API. Our target is a sourced roadmap in under three minutes, with no uncited recommendations. The seeded-profile checks are technical tests. They are not user research or proof of job placements. We measure whether a worker gets a dated plan they can start.</a:t>
             </a:r>
           </a:p>
         </p:txBody>
@@ -4220,7 +4291,7 @@
       <p:grpSpPr/>
       <p:pic>
         <p:nvPicPr>
-          <p:cNvPr id="2" name="Picture 1" descr="01 Team Information"/>
+          <p:cNvPr id="2" name="Picture 1" descr="slide-01.png"/>
           <p:cNvPicPr>
             <a:picLocks noChangeAspect="1"/>
           </p:cNvPicPr>
@@ -4262,7 +4333,7 @@
       <p:grpSpPr/>
       <p:pic>
         <p:nvPicPr>
-          <p:cNvPr id="2" name="Picture 1" descr="10 Technical Approach"/>
+          <p:cNvPr id="2" name="Picture 1" descr="slide-10.png"/>
           <p:cNvPicPr>
             <a:picLocks noChangeAspect="1"/>
           </p:cNvPicPr>
@@ -4304,7 +4375,49 @@
       <p:grpSpPr/>
       <p:pic>
         <p:nvPicPr>
-          <p:cNvPr id="2" name="Picture 1" descr="11 What We Want From You"/>
+          <p:cNvPr id="2" name="Picture 1" descr="slide-11.png"/>
+          <p:cNvPicPr>
+            <a:picLocks noChangeAspect="1"/>
+          </p:cNvPicPr>
+          <p:nvPr/>
+        </p:nvPicPr>
+        <p:blipFill>
+          <a:blip r:embed="rId2"/>
+          <a:stretch>
+            <a:fillRect/>
+          </a:stretch>
+        </p:blipFill>
+        <p:spPr>
+          <a:xfrm>
+            <a:off x="0" y="0"/>
+            <a:ext cx="12191695" cy="6858000"/>
+          </a:xfrm>
+          <a:prstGeom prst="rect">
+            <a:avLst/>
+          </a:prstGeom>
+        </p:spPr>
+      </p:pic>
+    </p:spTree>
+  </p:cSld>
+  <p:clrMapOvr>
+    <a:masterClrMapping/>
+  </p:clrMapOvr>
+</p:sld>
+</file>
+
+<file path=ppt/slides/slide12.xml><?xml version="1.0" encoding="utf-8"?>
+<p:sld xmlns:a="http://schemas.openxmlformats.org/drawingml/2006/main" xmlns:p="http://schemas.openxmlformats.org/presentationml/2006/main" xmlns:r="http://schemas.openxmlformats.org/officeDocument/2006/relationships">
+  <p:cSld>
+    <p:spTree>
+      <p:nvGrpSpPr>
+        <p:cNvPr id="1" name=""/>
+        <p:cNvGrpSpPr/>
+        <p:nvPr/>
+      </p:nvGrpSpPr>
+      <p:grpSpPr/>
+      <p:pic>
+        <p:nvPicPr>
+          <p:cNvPr id="2" name="Picture 1" descr="slide-12.png"/>
           <p:cNvPicPr>
             <a:picLocks noChangeAspect="1"/>
           </p:cNvPicPr>
@@ -4346,7 +4459,7 @@
       <p:grpSpPr/>
       <p:pic>
         <p:nvPicPr>
-          <p:cNvPr id="2" name="Picture 1" descr="02 The Problem"/>
+          <p:cNvPr id="2" name="Picture 1" descr="slide-02.png"/>
           <p:cNvPicPr>
             <a:picLocks noChangeAspect="1"/>
           </p:cNvPicPr>
@@ -4388,7 +4501,7 @@
       <p:grpSpPr/>
       <p:pic>
         <p:nvPicPr>
-          <p:cNvPr id="2" name="Picture 1" descr="03 The User"/>
+          <p:cNvPr id="2" name="Picture 1" descr="slide-03.png"/>
           <p:cNvPicPr>
             <a:picLocks noChangeAspect="1"/>
           </p:cNvPicPr>
@@ -4430,7 +4543,7 @@
       <p:grpSpPr/>
       <p:pic>
         <p:nvPicPr>
-          <p:cNvPr id="2" name="Picture 1" descr="04 The Solution"/>
+          <p:cNvPr id="2" name="Picture 1" descr="slide-04.png"/>
           <p:cNvPicPr>
             <a:picLocks noChangeAspect="1"/>
           </p:cNvPicPr>
@@ -4472,7 +4585,7 @@
       <p:grpSpPr/>
       <p:pic>
         <p:nvPicPr>
-          <p:cNvPr id="2" name="Picture 1" descr="05 How It Works"/>
+          <p:cNvPr id="2" name="Picture 1" descr="slide-05.png"/>
           <p:cNvPicPr>
             <a:picLocks noChangeAspect="1"/>
           </p:cNvPicPr>
@@ -4514,7 +4627,7 @@
       <p:grpSpPr/>
       <p:pic>
         <p:nvPicPr>
-          <p:cNvPr id="2" name="Picture 1" descr="06 Live Demo"/>
+          <p:cNvPr id="2" name="Picture 1" descr="slide-06.png"/>
           <p:cNvPicPr>
             <a:picLocks noChangeAspect="1"/>
           </p:cNvPicPr>
@@ -4556,7 +4669,7 @@
       <p:grpSpPr/>
       <p:pic>
         <p:nvPicPr>
-          <p:cNvPr id="2" name="Picture 1" descr="07 The Prototype"/>
+          <p:cNvPr id="2" name="Picture 1" descr="slide-07.png"/>
           <p:cNvPicPr>
             <a:picLocks noChangeAspect="1"/>
           </p:cNvPicPr>
@@ -4598,7 +4711,7 @@
       <p:grpSpPr/>
       <p:pic>
         <p:nvPicPr>
-          <p:cNvPr id="2" name="Picture 1" descr="08 Innovation"/>
+          <p:cNvPr id="2" name="Picture 1" descr="slide-08.png"/>
           <p:cNvPicPr>
             <a:picLocks noChangeAspect="1"/>
           </p:cNvPicPr>
@@ -4640,7 +4753,7 @@
       <p:grpSpPr/>
       <p:pic>
         <p:nvPicPr>
-          <p:cNvPr id="2" name="Picture 1" descr="09 Impact"/>
+          <p:cNvPr id="2" name="Picture 1" descr="slide-09.png"/>
           <p:cNvPicPr>
             <a:picLocks noChangeAspect="1"/>
           </p:cNvPicPr>

</xml_diff>

<commit_message>
docs: match the pitch deck to the build
The deck described features the build doesn't have. It now matches
the app on main:

- Slides 7, 8, 10 and 11 no longer present the National View page as
  built: agencies get totals through the API and tools, over sample
  rows, and slide 7 shows Connect Your AI instead.
- Slide 4 shows the real 12-week plan, without the fast-scenario hours.
- Slide 6 and its note show the real April to May changes for Web
  Developers.
- Screenshots retaken on main; the architecture image names Claude
  Haiku 5.5 and Neon's real contents. PDF and PPTX re-exported.

Co-Authored-By: Claude Opus 5.5 <noreply@anthropic.com>
</commit_message>
<xml_diff>
--- a/docs/demo/deck/kotak-pitch-deck.pptx
+++ b/docs/demo/deck/kotak-pitch-deck.pptx
@@ -583,7 +583,7 @@
           <a:lstStyle/>
           <a:p>
             <a:r>
-              <a:t>Workers use Kotak free. Employers are the payer. Next, they pay Kotak for a team view that helps them decide where to spend their training levy. That view is not built yet. The levy is separate from payment for Kotak. Registered employers pay one percent of wages plus fixed allowances each month, or half a percent in the optional category. They apply before training and claim approved costs. The HRD Corp FAQ is the source. Agencies get the built anonymous national view, for groups of ten or more. An employer's own HR assistant can call the same rules through MCP. Grants are a route to explore.</a:t>
+              <a:t>Workers use Kotak free. Employers are the payer. Next, they pay Kotak for a team view that helps them decide where to spend their training levy. That view is not built yet. The levy is separate from payment for Kotak. Registered employers pay one percent of wages plus fixed allowances each month, or half a percent in the optional category. They apply before training and claim approved costs. The HRD Corp FAQ is the source. Agencies can read anonymous skill-gap totals through Kotak's summary API and its AI tools, for groups of ten or more. Until real check-ups are collected, those totals are labelled sample rows. An employer's own HR assistant can call the same rules through MCP. Grants are a route to explore.</a:t>
             </a:r>
           </a:p>
         </p:txBody>
@@ -653,7 +653,7 @@
           <a:lstStyle/>
           <a:p>
             <a:r>
-              <a:t>The browser runs the rules over committed snapshots. A Cloudflare Worker serves the app and API. Neon stores anonymous national totals. Claude Haiku 5.5 explains the results; this matches the code. Live2D animates Kopi. ElevenLabs supplies cached voice. RunPod supports the batch build. Replit hosts the live demo. Cached answers and fixed text keep the verdict unchanged when Claude fails.</a:t>
+              <a:t>The browser runs the rules over committed snapshots. A Cloudflare Worker serves the app and API. Neon stores the JobStreet listings and reviews, the admin accounts and the national view's sample rows. Claude Haiku 5.5 explains the results; this matches the code. Live2D animates Kopi. ElevenLabs supplies cached voice. RunPod supports the batch build. Replit hosts the live demo. Cached answers and fixed text keep the verdict unchanged when Claude fails.</a:t>
             </a:r>
           </a:p>
         </p:txBody>
@@ -723,7 +723,7 @@
           <a:lstStyle/>
           <a:p>
             <a:r>
-              <a:t>Try the live demo with the sample profile. The demo QR opens the app. The code QR opens the Kotak repository. Connect Your AI is at slash app slash connect. Copy the MCP setup there. Your assistant calls the same rules as the web app. Data decides. AI explains.</a:t>
+              <a:t>Try the live demo with your own job. The demo QR opens the app. The code QR opens the Kotak repository. Connect Your AI is at slash app slash connect. Copy the MCP setup there. Your assistant calls the same rules as the web app. Data decides. AI explains.</a:t>
             </a:r>
           </a:p>
         </p:txBody>
@@ -933,7 +933,7 @@
           <a:lstStyle/>
           <a:p>
             <a:r>
-              <a:t>Aina leaves with a dated plan. This sample starts on 2 November 2026 and ends on 24 January 2027. Code review takes three hours a week. Accessibility and practice take four. The fast scenario adds two hours for testing. GitHub Skills, W3C WAI, MDN and freeCodeCamp are free. Other roles show unchecked search suggestions. The funding card tells a levy-paying employer to apply before training and claim only approved costs. The screenshot is the existing sample build. These cost and funding labels are part of the sample-plan update.</a:t>
+              <a:t>Aina leaves with a dated plan. On screen is the plan for her job, Web Developers, with the demo answers. It starts on 2 November 2026 and runs 12 weeks to 24 January 2027, at four hours a week. The Rising skill comes first: Technical documentation fills all 12 weeks, and about 622 hours of the full path remain after that. Each step links a free web search, labelled as a suggestion Kotak has not checked. The funding card tells a levy-paying employer to apply before training and claim only approved costs.</a:t>
             </a:r>
           </a:p>
         </p:txBody>
@@ -1073,7 +1073,7 @@
           <a:lstStyle/>
           <a:p>
             <a:r>
-              <a:t>This is the sample-data demo. Keep the same profile and answers. Change April to May. Testing moves from Split to Rising. Design Systems moves from Steady to Rising. The sample top match is Design Systems Developer at 74 percent. The roadmap adds testing. The sample shows how a new snapshot changes the plan.</a:t>
+              <a:t>This is the live demo, on the real snapshots. Keep the same profile and the same 12 answers: Web Developers, level 1 on every skill. In April, Kotak has one month of AI-use data, too few points for a trend, so every skill reads Unknown. Change April to May. Technical documentation and Web specifications and standards turn Rising. Web site building turns Declining. The other three turn Steady. Technical documentation moves from roadmap step 3 to step 1. Only the snapshot changed.</a:t>
             </a:r>
           </a:p>
         </p:txBody>
@@ -1143,7 +1143,7 @@
           <a:lstStyle/>
           <a:p>
             <a:r>
-              <a:t>These are screens from the prototype. The check-up starts with who the worker is: their situation, study, job and goal. Then the radar, roles and roadmap form the loop. Each role says why it is there, and the highlighted one says why Kopi picked it. The national view is built too. It hides groups smaller than ten. The app has phone and desktop layouts. Screens with sample data carry the Sample Data label.</a:t>
+              <a:t>These are screens from the prototype. The check-up starts with who the worker is: their situation, study, job and goal. Then the radar, roles and roadmap form the loop. Each role says why it is there, and the highlighted one says why Kopi picked it. Connect Your AI gives any assistant the same read-only tools over MCP. The app has phone and desktop layouts, and every verdict cites its dated sources.</a:t>
             </a:r>
           </a:p>
         </p:txBody>
@@ -1283,7 +1283,7 @@
           <a:lstStyle/>
           <a:p>
             <a:r>
-              <a:t>SDG target 4.4 concerns skills for work. DOSM provides the Malaysia baseline through the UN SDG API. Our target is a sourced roadmap in under three minutes, with no uncited recommendations. The seeded-profile checks are technical tests. They are not user research or proof of job placements. We measure whether a worker gets a dated plan they can start.</a:t>
+              <a:t>SDG target 4.4 concerns skills for work. DOSM provides the Malaysia baseline through the UN SDG API. Our target is a sourced roadmap in under three minutes, with no uncited recommendations. The 20 seeded profiles are a Phase 2 technical test, a target and not yet a result. They are not user research or proof of job placements. One check is met now: the build fails unless all three demo roles flip a verdict from April to May. We measure whether a worker gets a dated plan they can start.</a:t>
             </a:r>
           </a:p>
         </p:txBody>

</xml_diff>

<commit_message>
docs: frame the deck plan as 80% fit
Slides 4, 5 and 7 and note 4 now match the roadmap that plans to 80%
fit: Aina's plan at 10 h a week runs from 2 Nov 2026 to 4 Jul 2027 and
reaches 80% fit by week 35, with about 320 h left after it. Both roadmap
screenshots are retaken on the current build, and the PDF and PPTX are
re-exported.

Claude-Session: https://claude.ai/code/session_01BWsADUbB5qxgQmhDHW5h1W
</commit_message>
<xml_diff>
--- a/docs/demo/deck/kotak-pitch-deck.pptx
+++ b/docs/demo/deck/kotak-pitch-deck.pptx
@@ -18,7 +18,7 @@
     <p:sldId id="266" r:id="rId18"/>
     <p:sldId id="267" r:id="rId19"/>
   </p:sldIdLst>
-  <p:sldSz cx="12191695" cy="6858000" type="screen4x3"/>
+  <p:sldSz cx="12192000" cy="6858000" type="screen4x3"/>
   <p:notesSz cx="6858000" cy="9144000"/>
   <p:defaultTextStyle>
     <a:defPPr>
@@ -933,7 +933,7 @@
           <a:lstStyle/>
           <a:p>
             <a:r>
-              <a:t>Aina leaves with a dated plan. On screen is the plan for her job, Web Developers, with the demo answers. It starts on 2 November 2026 and runs 12 weeks to 24 January 2027, at four hours a week. The Rising skill comes first: Technical documentation fills all 12 weeks, and about 622 hours of the full path remain after that. Each step links a free web search, labelled as a suggestion Kotak has not checked. The funding card tells a levy-paying employer to apply before training and claim only approved costs.</a:t>
+              <a:t>Aina leaves with a dated plan. On screen is the plan for her job, Web Developers, with the demo answers. At ten hours a week it starts on 2 November 2026 and reaches 80 percent fit by week 35, on 4 July 2027. The Rising skill comes first: Technical documentation, then Web testing and updates. About 320 hours of the full path remain after week 35. Each step links a free web search, labelled as a suggestion Kotak has not checked. The funding card tells a levy-paying employer to apply before training and claim only approved costs.</a:t>
             </a:r>
           </a:p>
         </p:txBody>
@@ -4291,7 +4291,7 @@
       <p:grpSpPr/>
       <p:pic>
         <p:nvPicPr>
-          <p:cNvPr id="2" name="Picture 1" descr="slide-01.png"/>
+          <p:cNvPr id="2" name="Picture 1" descr="S01.png"/>
           <p:cNvPicPr>
             <a:picLocks noChangeAspect="1"/>
           </p:cNvPicPr>
@@ -4306,7 +4306,7 @@
         <p:spPr>
           <a:xfrm>
             <a:off x="0" y="0"/>
-            <a:ext cx="12191695" cy="6858000"/>
+            <a:ext cx="12192000" cy="6858000"/>
           </a:xfrm>
           <a:prstGeom prst="rect">
             <a:avLst/>
@@ -4333,7 +4333,7 @@
       <p:grpSpPr/>
       <p:pic>
         <p:nvPicPr>
-          <p:cNvPr id="2" name="Picture 1" descr="slide-10.png"/>
+          <p:cNvPr id="2" name="Picture 1" descr="S10.png"/>
           <p:cNvPicPr>
             <a:picLocks noChangeAspect="1"/>
           </p:cNvPicPr>
@@ -4348,7 +4348,7 @@
         <p:spPr>
           <a:xfrm>
             <a:off x="0" y="0"/>
-            <a:ext cx="12191695" cy="6858000"/>
+            <a:ext cx="12192000" cy="6858000"/>
           </a:xfrm>
           <a:prstGeom prst="rect">
             <a:avLst/>
@@ -4375,7 +4375,7 @@
       <p:grpSpPr/>
       <p:pic>
         <p:nvPicPr>
-          <p:cNvPr id="2" name="Picture 1" descr="slide-11.png"/>
+          <p:cNvPr id="2" name="Picture 1" descr="S11.png"/>
           <p:cNvPicPr>
             <a:picLocks noChangeAspect="1"/>
           </p:cNvPicPr>
@@ -4390,7 +4390,7 @@
         <p:spPr>
           <a:xfrm>
             <a:off x="0" y="0"/>
-            <a:ext cx="12191695" cy="6858000"/>
+            <a:ext cx="12192000" cy="6858000"/>
           </a:xfrm>
           <a:prstGeom prst="rect">
             <a:avLst/>
@@ -4417,7 +4417,7 @@
       <p:grpSpPr/>
       <p:pic>
         <p:nvPicPr>
-          <p:cNvPr id="2" name="Picture 1" descr="slide-12.png"/>
+          <p:cNvPr id="2" name="Picture 1" descr="S12.png"/>
           <p:cNvPicPr>
             <a:picLocks noChangeAspect="1"/>
           </p:cNvPicPr>
@@ -4432,7 +4432,7 @@
         <p:spPr>
           <a:xfrm>
             <a:off x="0" y="0"/>
-            <a:ext cx="12191695" cy="6858000"/>
+            <a:ext cx="12192000" cy="6858000"/>
           </a:xfrm>
           <a:prstGeom prst="rect">
             <a:avLst/>
@@ -4459,7 +4459,7 @@
       <p:grpSpPr/>
       <p:pic>
         <p:nvPicPr>
-          <p:cNvPr id="2" name="Picture 1" descr="slide-02.png"/>
+          <p:cNvPr id="2" name="Picture 1" descr="S02.png"/>
           <p:cNvPicPr>
             <a:picLocks noChangeAspect="1"/>
           </p:cNvPicPr>
@@ -4474,7 +4474,7 @@
         <p:spPr>
           <a:xfrm>
             <a:off x="0" y="0"/>
-            <a:ext cx="12191695" cy="6858000"/>
+            <a:ext cx="12192000" cy="6858000"/>
           </a:xfrm>
           <a:prstGeom prst="rect">
             <a:avLst/>
@@ -4501,7 +4501,7 @@
       <p:grpSpPr/>
       <p:pic>
         <p:nvPicPr>
-          <p:cNvPr id="2" name="Picture 1" descr="slide-03.png"/>
+          <p:cNvPr id="2" name="Picture 1" descr="S03.png"/>
           <p:cNvPicPr>
             <a:picLocks noChangeAspect="1"/>
           </p:cNvPicPr>
@@ -4516,7 +4516,7 @@
         <p:spPr>
           <a:xfrm>
             <a:off x="0" y="0"/>
-            <a:ext cx="12191695" cy="6858000"/>
+            <a:ext cx="12192000" cy="6858000"/>
           </a:xfrm>
           <a:prstGeom prst="rect">
             <a:avLst/>
@@ -4543,7 +4543,7 @@
       <p:grpSpPr/>
       <p:pic>
         <p:nvPicPr>
-          <p:cNvPr id="2" name="Picture 1" descr="slide-04.png"/>
+          <p:cNvPr id="2" name="Picture 1" descr="S04.png"/>
           <p:cNvPicPr>
             <a:picLocks noChangeAspect="1"/>
           </p:cNvPicPr>
@@ -4558,7 +4558,7 @@
         <p:spPr>
           <a:xfrm>
             <a:off x="0" y="0"/>
-            <a:ext cx="12191695" cy="6858000"/>
+            <a:ext cx="12192000" cy="6858000"/>
           </a:xfrm>
           <a:prstGeom prst="rect">
             <a:avLst/>
@@ -4585,7 +4585,7 @@
       <p:grpSpPr/>
       <p:pic>
         <p:nvPicPr>
-          <p:cNvPr id="2" name="Picture 1" descr="slide-05.png"/>
+          <p:cNvPr id="2" name="Picture 1" descr="S05.png"/>
           <p:cNvPicPr>
             <a:picLocks noChangeAspect="1"/>
           </p:cNvPicPr>
@@ -4600,7 +4600,7 @@
         <p:spPr>
           <a:xfrm>
             <a:off x="0" y="0"/>
-            <a:ext cx="12191695" cy="6858000"/>
+            <a:ext cx="12192000" cy="6858000"/>
           </a:xfrm>
           <a:prstGeom prst="rect">
             <a:avLst/>
@@ -4627,7 +4627,7 @@
       <p:grpSpPr/>
       <p:pic>
         <p:nvPicPr>
-          <p:cNvPr id="2" name="Picture 1" descr="slide-06.png"/>
+          <p:cNvPr id="2" name="Picture 1" descr="S06.png"/>
           <p:cNvPicPr>
             <a:picLocks noChangeAspect="1"/>
           </p:cNvPicPr>
@@ -4642,7 +4642,7 @@
         <p:spPr>
           <a:xfrm>
             <a:off x="0" y="0"/>
-            <a:ext cx="12191695" cy="6858000"/>
+            <a:ext cx="12192000" cy="6858000"/>
           </a:xfrm>
           <a:prstGeom prst="rect">
             <a:avLst/>
@@ -4669,7 +4669,7 @@
       <p:grpSpPr/>
       <p:pic>
         <p:nvPicPr>
-          <p:cNvPr id="2" name="Picture 1" descr="slide-07.png"/>
+          <p:cNvPr id="2" name="Picture 1" descr="S07.png"/>
           <p:cNvPicPr>
             <a:picLocks noChangeAspect="1"/>
           </p:cNvPicPr>
@@ -4684,7 +4684,7 @@
         <p:spPr>
           <a:xfrm>
             <a:off x="0" y="0"/>
-            <a:ext cx="12191695" cy="6858000"/>
+            <a:ext cx="12192000" cy="6858000"/>
           </a:xfrm>
           <a:prstGeom prst="rect">
             <a:avLst/>
@@ -4711,7 +4711,7 @@
       <p:grpSpPr/>
       <p:pic>
         <p:nvPicPr>
-          <p:cNvPr id="2" name="Picture 1" descr="slide-08.png"/>
+          <p:cNvPr id="2" name="Picture 1" descr="S08.png"/>
           <p:cNvPicPr>
             <a:picLocks noChangeAspect="1"/>
           </p:cNvPicPr>
@@ -4726,7 +4726,7 @@
         <p:spPr>
           <a:xfrm>
             <a:off x="0" y="0"/>
-            <a:ext cx="12191695" cy="6858000"/>
+            <a:ext cx="12192000" cy="6858000"/>
           </a:xfrm>
           <a:prstGeom prst="rect">
             <a:avLst/>
@@ -4753,7 +4753,7 @@
       <p:grpSpPr/>
       <p:pic>
         <p:nvPicPr>
-          <p:cNvPr id="2" name="Picture 1" descr="slide-09.png"/>
+          <p:cNvPr id="2" name="Picture 1" descr="S09.png"/>
           <p:cNvPicPr>
             <a:picLocks noChangeAspect="1"/>
           </p:cNvPicPr>
@@ -4768,7 +4768,7 @@
         <p:spPr>
           <a:xfrm>
             <a:off x="0" y="0"/>
-            <a:ext cx="12191695" cy="6858000"/>
+            <a:ext cx="12192000" cy="6858000"/>
           </a:xfrm>
           <a:prstGeom prst="rect">
             <a:avLst/>

</xml_diff>

<commit_message>
docs: redesign the pitch deck for the video
Ten slides in the order of the director script, less text per slide, and white-clay art on six of them. Slide 2 uses one PERKESO dataset (52,607 to 16 Jul 2026, 51% professionals). Slide 8 no longer implies the levy pays for Kotak.

Claude-Session: https://claude.ai/code/session_01BWsADUbB5qxgQmhDHW5h1W
</commit_message>
<xml_diff>
--- a/docs/demo/deck/kotak-pitch-deck.pptx
+++ b/docs/demo/deck/kotak-pitch-deck.pptx
@@ -15,8 +15,6 @@
     <p:sldId id="263" r:id="rId15"/>
     <p:sldId id="264" r:id="rId16"/>
     <p:sldId id="265" r:id="rId17"/>
-    <p:sldId id="266" r:id="rId18"/>
-    <p:sldId id="267" r:id="rId19"/>
   </p:sldIdLst>
   <p:sldSz cx="12192000" cy="6858000" type="screen4x3"/>
   <p:notesSz cx="6858000" cy="9144000"/>
@@ -513,7 +511,7 @@
           <a:lstStyle/>
           <a:p>
             <a:r>
-              <a:t>Kotak is for software and digital workers in Malaysia. We focus on developers, testers and designers at employers that pay the HRD Corp levy. They get a plan for what to learn next. We are Team T010NG. The build is live on Replit.</a:t>
+              <a:t>Hi, we're Team T010NG. Tolong is Malay for help. We're in Domain 1, the future-ready workforce, and we built Kotak. It shows a worker what AI is changing in their job, and what to learn next.</a:t>
             </a:r>
           </a:p>
         </p:txBody>
@@ -583,147 +581,7 @@
           <a:lstStyle/>
           <a:p>
             <a:r>
-              <a:t>Workers use Kotak free. Employers are the payer. Next, they pay Kotak for a team view that helps them decide where to spend their training levy. That view is not built yet. The levy is separate from payment for Kotak. Registered employers pay one percent of wages plus fixed allowances each month, or half a percent in the optional category. They apply before training and claim approved costs. The HRD Corp FAQ is the source. Agencies can read anonymous skill-gap totals through Kotak's summary API and its AI tools, for groups of ten or more. Until real check-ups are collected, those totals are labelled sample rows. An employer's own HR assistant can call the same rules through MCP. Grants are a route to explore.</a:t>
-            </a:r>
-          </a:p>
-        </p:txBody>
-      </p:sp>
-      <p:sp>
-        <p:nvSpPr>
-          <p:cNvPr id="4" name="Slide Number Placeholder 3"/>
-          <p:cNvSpPr>
-            <a:spLocks noGrp="1"/>
-          </p:cNvSpPr>
-          <p:nvPr>
-            <p:ph type="sldNum" idx="5" sz="quarter"/>
-          </p:nvPr>
-        </p:nvSpPr>
-        <p:spPr/>
-      </p:sp>
-    </p:spTree>
-  </p:cSld>
-  <p:clrMapOvr>
-    <a:masterClrMapping/>
-  </p:clrMapOvr>
-</p:notes>
-</file>
-
-<file path=ppt/notesSlides/notesSlide11.xml><?xml version="1.0" encoding="utf-8"?>
-<p:notes xmlns:a="http://schemas.openxmlformats.org/drawingml/2006/main" xmlns:p="http://schemas.openxmlformats.org/presentationml/2006/main" xmlns:r="http://schemas.openxmlformats.org/officeDocument/2006/relationships">
-  <p:cSld>
-    <p:spTree>
-      <p:nvGrpSpPr>
-        <p:cNvPr id="1" name=""/>
-        <p:cNvGrpSpPr/>
-        <p:nvPr/>
-      </p:nvGrpSpPr>
-      <p:grpSpPr>
-        <a:xfrm>
-          <a:off x="0" y="0"/>
-          <a:ext cx="0" cy="0"/>
-          <a:chOff x="0" y="0"/>
-          <a:chExt cx="0" cy="0"/>
-        </a:xfrm>
-      </p:grpSpPr>
-      <p:sp>
-        <p:nvSpPr>
-          <p:cNvPr id="2" name="Slide Image Placeholder 1"/>
-          <p:cNvSpPr>
-            <a:spLocks noGrp="1"/>
-          </p:cNvSpPr>
-          <p:nvPr>
-            <p:ph type="sldImg" idx="2"/>
-          </p:nvPr>
-        </p:nvSpPr>
-        <p:spPr/>
-      </p:sp>
-      <p:sp>
-        <p:nvSpPr>
-          <p:cNvPr id="3" name="Notes Placeholder 2"/>
-          <p:cNvSpPr>
-            <a:spLocks noGrp="1"/>
-          </p:cNvSpPr>
-          <p:nvPr>
-            <p:ph type="body" idx="3" sz="quarter"/>
-          </p:nvPr>
-        </p:nvSpPr>
-        <p:spPr/>
-        <p:txBody>
-          <a:bodyPr/>
-          <a:lstStyle/>
-          <a:p>
-            <a:r>
-              <a:t>The browser runs the rules over committed snapshots. A Cloudflare Worker serves the app and API. Neon stores the JobStreet listings and reviews, the admin accounts and the national view's sample rows. Claude Haiku 5.5 explains the results; this matches the code. Live2D animates Kopi. ElevenLabs supplies cached voice. RunPod supports the batch build. Replit hosts the live demo. Cached answers and fixed text keep the verdict unchanged when Claude fails.</a:t>
-            </a:r>
-          </a:p>
-        </p:txBody>
-      </p:sp>
-      <p:sp>
-        <p:nvSpPr>
-          <p:cNvPr id="4" name="Slide Number Placeholder 3"/>
-          <p:cNvSpPr>
-            <a:spLocks noGrp="1"/>
-          </p:cNvSpPr>
-          <p:nvPr>
-            <p:ph type="sldNum" idx="5" sz="quarter"/>
-          </p:nvPr>
-        </p:nvSpPr>
-        <p:spPr/>
-      </p:sp>
-    </p:spTree>
-  </p:cSld>
-  <p:clrMapOvr>
-    <a:masterClrMapping/>
-  </p:clrMapOvr>
-</p:notes>
-</file>
-
-<file path=ppt/notesSlides/notesSlide12.xml><?xml version="1.0" encoding="utf-8"?>
-<p:notes xmlns:a="http://schemas.openxmlformats.org/drawingml/2006/main" xmlns:p="http://schemas.openxmlformats.org/presentationml/2006/main" xmlns:r="http://schemas.openxmlformats.org/officeDocument/2006/relationships">
-  <p:cSld>
-    <p:spTree>
-      <p:nvGrpSpPr>
-        <p:cNvPr id="1" name=""/>
-        <p:cNvGrpSpPr/>
-        <p:nvPr/>
-      </p:nvGrpSpPr>
-      <p:grpSpPr>
-        <a:xfrm>
-          <a:off x="0" y="0"/>
-          <a:ext cx="0" cy="0"/>
-          <a:chOff x="0" y="0"/>
-          <a:chExt cx="0" cy="0"/>
-        </a:xfrm>
-      </p:grpSpPr>
-      <p:sp>
-        <p:nvSpPr>
-          <p:cNvPr id="2" name="Slide Image Placeholder 1"/>
-          <p:cNvSpPr>
-            <a:spLocks noGrp="1"/>
-          </p:cNvSpPr>
-          <p:nvPr>
-            <p:ph type="sldImg" idx="2"/>
-          </p:nvPr>
-        </p:nvSpPr>
-        <p:spPr/>
-      </p:sp>
-      <p:sp>
-        <p:nvSpPr>
-          <p:cNvPr id="3" name="Notes Placeholder 2"/>
-          <p:cNvSpPr>
-            <a:spLocks noGrp="1"/>
-          </p:cNvSpPr>
-          <p:nvPr>
-            <p:ph type="body" idx="3" sz="quarter"/>
-          </p:nvPr>
-        </p:nvSpPr>
-        <p:spPr/>
-        <p:txBody>
-          <a:bodyPr/>
-          <a:lstStyle/>
-          <a:p>
-            <a:r>
-              <a:t>Try the live demo with your own job. The demo QR opens the app. The code QR opens the Kotak repository. Connect Your AI is at slash app slash connect. Copy the MCP setup there. Your assistant calls the same rules as the web app. Data decides. AI explains.</a:t>
+              <a:t>Aina doesn't need another course list. She needs to know where to start. Kotak is Malay for box. Data decides. AI explains. We're Team T010NG. Thank you.</a:t>
             </a:r>
           </a:p>
         </p:txBody>
@@ -793,7 +651,7 @@
           <a:lstStyle/>
           <a:p>
             <a:r>
-              <a:t>These are national figures, not figures for software workers alone. Hays reports 56 percent use AI and 26 percent have formal training. TalentCorp projects 620,000 workers affected in the sectors studied. World Bank and ISIS Malaysia report 28 percent highly exposed. Our moment is a manager deciding what training to fund as AI coding tools arrive.</a:t>
+              <a:t>By mid-July 2026, 52,607 Malaysians had lost their jobs, about 270 a day. Half were professionals, managers, executives or technicians; in 1998 and 2009 production workers were hit hardest. This time, it's the office. The minister says AI isn't a main cause yet, but ISIS Malaysia found the most AI-exposed jobs see 69% more job losses than average. 56% of Malaysian professionals use AI at work; only 26% have been trained.</a:t>
             </a:r>
           </a:p>
         </p:txBody>
@@ -863,7 +721,7 @@
           <a:lstStyle/>
           <a:p>
             <a:r>
-              <a:t>Aina is a sample persona. We invented her for this pitch. She is a front-end developer in Kuala Lumpur. Her employer pays the HRD Corp levy. The company rolls out AI coding tools. Her manager asks what training to fund this year. She needs a plan she can show him. The engine covers 923 jobs. Our first group is software and digital workers.</a:t>
+              <a:t>Kotak is for developers, testers and designers at levy-paying employers, the week AI tools arrive. Aina is a sample persona; her manager asks which training to fund.</a:t>
             </a:r>
           </a:p>
         </p:txBody>
@@ -933,7 +791,7 @@
           <a:lstStyle/>
           <a:p>
             <a:r>
-              <a:t>Aina leaves with a dated plan. On screen is the plan for her job, Web Developers, with the demo answers. At ten hours a week it starts on 2 November 2026 and reaches 80 percent fit by week 35, on 4 July 2027. The Rising skill comes first: Technical documentation, then Web testing and updates. About 320 hours of the full path remain after week 35. Each step links a free web search, labelled as a suggestion Kotak has not checked. The funding card tells a levy-paying employer to apply before training and claim only approved costs.</a:t>
+              <a:t>A course list can't answer that. Kotak can, in a three-minute check-up: 12 questions, no CV. She leaves with a dated plan: which skill first, the hours each week, a free step for each skill, and her employer's funding route. Her manager sees the dated evidence behind every step.</a:t>
             </a:r>
           </a:p>
         </p:txBody>
@@ -1003,7 +861,7 @@
           <a:lstStyle/>
           <a:p>
             <a:r>
-              <a:t>Dated snapshots feed fixed rules. The browser sets verdicts, scores and plan order. RunPod drafts skills and questions offline. Claude explains the cited rows. Kopi reads its lines aloud. Text and mute stay available. AI never sets a verdict. If it fails, a fixed template answers. Split and Unknown are valid results.</a:t>
+              <a:t>Data decides, AI explains. Answer 12 questions; fixed rules compare them with dated public data; you get a radar, ranked roles and a plan. AI never sets a verdict.</a:t>
             </a:r>
           </a:p>
         </p:txBody>
@@ -1073,7 +931,7 @@
           <a:lstStyle/>
           <a:p>
             <a:r>
-              <a:t>This is the live demo, on the real snapshots. Keep the same profile and the same 12 answers: Web Developers, level 1 on every skill. In April, Kotak has one month of AI-use data, too few points for a trend, so every skill reads Unknown. Change April to May. Technical documentation and Web specifications and standards turn Rising. Web site building turns Declining. The other three turn Steady. Web site building moves from roadmap step 4 to step 6, the last. Only the snapshot changed.</a:t>
+              <a:t>Courses are the supply; Kotak sets the priority. Of the tools we reviewed, only Kotak has a dated AI trend per skill, visible fixed maths, a timed plan to a fit target, a funding route, and an MCP server: the tool a chatbot calls.</a:t>
             </a:r>
           </a:p>
         </p:txBody>
@@ -1143,7 +1001,7 @@
           <a:lstStyle/>
           <a:p>
             <a:r>
-              <a:t>These are screens from the prototype. The check-up starts with who the worker is: their situation, study, job and goal. Then the radar, roles and roadmap form the loop. Each role says why it is there, and the highlighted one says why Kopi picked it. Connect Your AI gives any assistant the same read-only tools over MCP. The app has phone and desktop layouts, and every verdict cites its dated sources.</a:t>
+              <a:t>From at risk to ready, with receipts. 697,000 jobs are significantly affected within 3 to 5 years without upskilling; the SDG 4.4.1 baseline is 39.8%; RM2.5 billion of levy was collected for training in 2025.</a:t>
             </a:r>
           </a:p>
         </p:txBody>
@@ -1213,7 +1071,7 @@
           <a:lstStyle/>
           <a:p>
             <a:r>
-              <a:t>MyMahir maps roles and skills. LinkedIn compares skills across roles. MasterClass offers expert video courses by subscription. ReSkills is a Malaysian subscription platform for live online classes. Its provider claim is attributed to NST in 2021. e-LATiH offers free and premium courses. They offer courses. Kotak tells you which skill to learn first and why now, then points you to them. The dated rules and timed plan are our contribution.</a:t>
+              <a:t>Workers use Kotak free. Employers pay for a team view: RM5 per worker a month. For a developer on the median advertised pay the levy is RM63 a month, so Kotak costs under a tenth of it. Agencies license anonymous national totals. Prices to test, not contracts; the team view is our next build.</a:t>
             </a:r>
           </a:p>
         </p:txBody>
@@ -1283,7 +1141,7 @@
           <a:lstStyle/>
           <a:p>
             <a:r>
-              <a:t>SDG target 4.4 concerns skills for work. DOSM provides the Malaysia baseline through the UN SDG API. Our target is a sourced roadmap in under three minutes, with no uncited recommendations. The 20 seeded profiles are a Phase 2 technical test, a target and not yet a result. They are not user research or proof of job placements. One check is met now: the build fails unless all three demo roles flip a verdict from April to May. We measure whether a worker gets a dated plan they can start.</a:t>
+              <a:t>Two halves, one rulebook, no guessing. The data half builds dated snapshots; the product half runs the same rules in the browser and over MCP. AI only explains, and a check rejects any explanation that changes a verdict.</a:t>
             </a:r>
           </a:p>
         </p:txBody>
@@ -4334,90 +4192,6 @@
       <p:pic>
         <p:nvPicPr>
           <p:cNvPr id="2" name="Picture 1" descr="S10.png"/>
-          <p:cNvPicPr>
-            <a:picLocks noChangeAspect="1"/>
-          </p:cNvPicPr>
-          <p:nvPr/>
-        </p:nvPicPr>
-        <p:blipFill>
-          <a:blip r:embed="rId2"/>
-          <a:stretch>
-            <a:fillRect/>
-          </a:stretch>
-        </p:blipFill>
-        <p:spPr>
-          <a:xfrm>
-            <a:off x="0" y="0"/>
-            <a:ext cx="12192000" cy="6858000"/>
-          </a:xfrm>
-          <a:prstGeom prst="rect">
-            <a:avLst/>
-          </a:prstGeom>
-        </p:spPr>
-      </p:pic>
-    </p:spTree>
-  </p:cSld>
-  <p:clrMapOvr>
-    <a:masterClrMapping/>
-  </p:clrMapOvr>
-</p:sld>
-</file>
-
-<file path=ppt/slides/slide11.xml><?xml version="1.0" encoding="utf-8"?>
-<p:sld xmlns:a="http://schemas.openxmlformats.org/drawingml/2006/main" xmlns:p="http://schemas.openxmlformats.org/presentationml/2006/main" xmlns:r="http://schemas.openxmlformats.org/officeDocument/2006/relationships">
-  <p:cSld>
-    <p:spTree>
-      <p:nvGrpSpPr>
-        <p:cNvPr id="1" name=""/>
-        <p:cNvGrpSpPr/>
-        <p:nvPr/>
-      </p:nvGrpSpPr>
-      <p:grpSpPr/>
-      <p:pic>
-        <p:nvPicPr>
-          <p:cNvPr id="2" name="Picture 1" descr="S11.png"/>
-          <p:cNvPicPr>
-            <a:picLocks noChangeAspect="1"/>
-          </p:cNvPicPr>
-          <p:nvPr/>
-        </p:nvPicPr>
-        <p:blipFill>
-          <a:blip r:embed="rId2"/>
-          <a:stretch>
-            <a:fillRect/>
-          </a:stretch>
-        </p:blipFill>
-        <p:spPr>
-          <a:xfrm>
-            <a:off x="0" y="0"/>
-            <a:ext cx="12192000" cy="6858000"/>
-          </a:xfrm>
-          <a:prstGeom prst="rect">
-            <a:avLst/>
-          </a:prstGeom>
-        </p:spPr>
-      </p:pic>
-    </p:spTree>
-  </p:cSld>
-  <p:clrMapOvr>
-    <a:masterClrMapping/>
-  </p:clrMapOvr>
-</p:sld>
-</file>
-
-<file path=ppt/slides/slide12.xml><?xml version="1.0" encoding="utf-8"?>
-<p:sld xmlns:a="http://schemas.openxmlformats.org/drawingml/2006/main" xmlns:p="http://schemas.openxmlformats.org/presentationml/2006/main" xmlns:r="http://schemas.openxmlformats.org/officeDocument/2006/relationships">
-  <p:cSld>
-    <p:spTree>
-      <p:nvGrpSpPr>
-        <p:cNvPr id="1" name=""/>
-        <p:cNvGrpSpPr/>
-        <p:nvPr/>
-      </p:nvGrpSpPr>
-      <p:grpSpPr/>
-      <p:pic>
-        <p:nvPicPr>
-          <p:cNvPr id="2" name="Picture 1" descr="S12.png"/>
           <p:cNvPicPr>
             <a:picLocks noChangeAspect="1"/>
           </p:cNvPicPr>

</xml_diff>

<commit_message>
docs: redesign the pitch deck for the video (#6)
Ten slides in the order of the director script, less text per slide, and white-clay art on six of them. Slide 2 uses one PERKESO dataset (52,607 to 16 Jul 2026, 51% professionals). Slide 8 no longer implies the levy pays for Kotak.

Claude-Session: https://claude.ai/code/session_01BWsADUbB5qxgQmhDHW5h1W
</commit_message>
<xml_diff>
--- a/docs/demo/deck/kotak-pitch-deck.pptx
+++ b/docs/demo/deck/kotak-pitch-deck.pptx
@@ -15,8 +15,6 @@
     <p:sldId id="263" r:id="rId15"/>
     <p:sldId id="264" r:id="rId16"/>
     <p:sldId id="265" r:id="rId17"/>
-    <p:sldId id="266" r:id="rId18"/>
-    <p:sldId id="267" r:id="rId19"/>
   </p:sldIdLst>
   <p:sldSz cx="12192000" cy="6858000" type="screen4x3"/>
   <p:notesSz cx="6858000" cy="9144000"/>
@@ -513,7 +511,7 @@
           <a:lstStyle/>
           <a:p>
             <a:r>
-              <a:t>Kotak is for software and digital workers in Malaysia. We focus on developers, testers and designers at employers that pay the HRD Corp levy. They get a plan for what to learn next. We are Team T010NG. The build is live on Replit.</a:t>
+              <a:t>Hi, we're Team T010NG. Tolong is Malay for help. We're in Domain 1, the future-ready workforce, and we built Kotak. It shows a worker what AI is changing in their job, and what to learn next.</a:t>
             </a:r>
           </a:p>
         </p:txBody>
@@ -583,147 +581,7 @@
           <a:lstStyle/>
           <a:p>
             <a:r>
-              <a:t>Workers use Kotak free. Employers are the payer. Next, they pay Kotak for a team view that helps them decide where to spend their training levy. That view is not built yet. The levy is separate from payment for Kotak. Registered employers pay one percent of wages plus fixed allowances each month, or half a percent in the optional category. They apply before training and claim approved costs. The HRD Corp FAQ is the source. Agencies can read anonymous skill-gap totals through Kotak's summary API and its AI tools, for groups of ten or more. Until real check-ups are collected, those totals are labelled sample rows. An employer's own HR assistant can call the same rules through MCP. Grants are a route to explore.</a:t>
-            </a:r>
-          </a:p>
-        </p:txBody>
-      </p:sp>
-      <p:sp>
-        <p:nvSpPr>
-          <p:cNvPr id="4" name="Slide Number Placeholder 3"/>
-          <p:cNvSpPr>
-            <a:spLocks noGrp="1"/>
-          </p:cNvSpPr>
-          <p:nvPr>
-            <p:ph type="sldNum" idx="5" sz="quarter"/>
-          </p:nvPr>
-        </p:nvSpPr>
-        <p:spPr/>
-      </p:sp>
-    </p:spTree>
-  </p:cSld>
-  <p:clrMapOvr>
-    <a:masterClrMapping/>
-  </p:clrMapOvr>
-</p:notes>
-</file>
-
-<file path=ppt/notesSlides/notesSlide11.xml><?xml version="1.0" encoding="utf-8"?>
-<p:notes xmlns:a="http://schemas.openxmlformats.org/drawingml/2006/main" xmlns:p="http://schemas.openxmlformats.org/presentationml/2006/main" xmlns:r="http://schemas.openxmlformats.org/officeDocument/2006/relationships">
-  <p:cSld>
-    <p:spTree>
-      <p:nvGrpSpPr>
-        <p:cNvPr id="1" name=""/>
-        <p:cNvGrpSpPr/>
-        <p:nvPr/>
-      </p:nvGrpSpPr>
-      <p:grpSpPr>
-        <a:xfrm>
-          <a:off x="0" y="0"/>
-          <a:ext cx="0" cy="0"/>
-          <a:chOff x="0" y="0"/>
-          <a:chExt cx="0" cy="0"/>
-        </a:xfrm>
-      </p:grpSpPr>
-      <p:sp>
-        <p:nvSpPr>
-          <p:cNvPr id="2" name="Slide Image Placeholder 1"/>
-          <p:cNvSpPr>
-            <a:spLocks noGrp="1"/>
-          </p:cNvSpPr>
-          <p:nvPr>
-            <p:ph type="sldImg" idx="2"/>
-          </p:nvPr>
-        </p:nvSpPr>
-        <p:spPr/>
-      </p:sp>
-      <p:sp>
-        <p:nvSpPr>
-          <p:cNvPr id="3" name="Notes Placeholder 2"/>
-          <p:cNvSpPr>
-            <a:spLocks noGrp="1"/>
-          </p:cNvSpPr>
-          <p:nvPr>
-            <p:ph type="body" idx="3" sz="quarter"/>
-          </p:nvPr>
-        </p:nvSpPr>
-        <p:spPr/>
-        <p:txBody>
-          <a:bodyPr/>
-          <a:lstStyle/>
-          <a:p>
-            <a:r>
-              <a:t>The browser runs the rules over committed snapshots. A Cloudflare Worker serves the app and API. Neon stores the JobStreet listings and reviews, the admin accounts and the national view's sample rows. Claude Haiku 5.5 explains the results; this matches the code. Live2D animates Kopi. ElevenLabs supplies cached voice. RunPod supports the batch build. Replit hosts the live demo. Cached answers and fixed text keep the verdict unchanged when Claude fails.</a:t>
-            </a:r>
-          </a:p>
-        </p:txBody>
-      </p:sp>
-      <p:sp>
-        <p:nvSpPr>
-          <p:cNvPr id="4" name="Slide Number Placeholder 3"/>
-          <p:cNvSpPr>
-            <a:spLocks noGrp="1"/>
-          </p:cNvSpPr>
-          <p:nvPr>
-            <p:ph type="sldNum" idx="5" sz="quarter"/>
-          </p:nvPr>
-        </p:nvSpPr>
-        <p:spPr/>
-      </p:sp>
-    </p:spTree>
-  </p:cSld>
-  <p:clrMapOvr>
-    <a:masterClrMapping/>
-  </p:clrMapOvr>
-</p:notes>
-</file>
-
-<file path=ppt/notesSlides/notesSlide12.xml><?xml version="1.0" encoding="utf-8"?>
-<p:notes xmlns:a="http://schemas.openxmlformats.org/drawingml/2006/main" xmlns:p="http://schemas.openxmlformats.org/presentationml/2006/main" xmlns:r="http://schemas.openxmlformats.org/officeDocument/2006/relationships">
-  <p:cSld>
-    <p:spTree>
-      <p:nvGrpSpPr>
-        <p:cNvPr id="1" name=""/>
-        <p:cNvGrpSpPr/>
-        <p:nvPr/>
-      </p:nvGrpSpPr>
-      <p:grpSpPr>
-        <a:xfrm>
-          <a:off x="0" y="0"/>
-          <a:ext cx="0" cy="0"/>
-          <a:chOff x="0" y="0"/>
-          <a:chExt cx="0" cy="0"/>
-        </a:xfrm>
-      </p:grpSpPr>
-      <p:sp>
-        <p:nvSpPr>
-          <p:cNvPr id="2" name="Slide Image Placeholder 1"/>
-          <p:cNvSpPr>
-            <a:spLocks noGrp="1"/>
-          </p:cNvSpPr>
-          <p:nvPr>
-            <p:ph type="sldImg" idx="2"/>
-          </p:nvPr>
-        </p:nvSpPr>
-        <p:spPr/>
-      </p:sp>
-      <p:sp>
-        <p:nvSpPr>
-          <p:cNvPr id="3" name="Notes Placeholder 2"/>
-          <p:cNvSpPr>
-            <a:spLocks noGrp="1"/>
-          </p:cNvSpPr>
-          <p:nvPr>
-            <p:ph type="body" idx="3" sz="quarter"/>
-          </p:nvPr>
-        </p:nvSpPr>
-        <p:spPr/>
-        <p:txBody>
-          <a:bodyPr/>
-          <a:lstStyle/>
-          <a:p>
-            <a:r>
-              <a:t>Try the live demo with your own job. The demo QR opens the app. The code QR opens the Kotak repository. Connect Your AI is at slash app slash connect. Copy the MCP setup there. Your assistant calls the same rules as the web app. Data decides. AI explains.</a:t>
+              <a:t>Aina doesn't need another course list. She needs to know where to start. Kotak is Malay for box. Data decides. AI explains. We're Team T010NG. Thank you.</a:t>
             </a:r>
           </a:p>
         </p:txBody>
@@ -793,7 +651,7 @@
           <a:lstStyle/>
           <a:p>
             <a:r>
-              <a:t>These are national figures, not figures for software workers alone. Hays reports 56 percent use AI and 26 percent have formal training. TalentCorp projects 620,000 workers affected in the sectors studied. World Bank and ISIS Malaysia report 28 percent highly exposed. Our moment is a manager deciding what training to fund as AI coding tools arrive.</a:t>
+              <a:t>By mid-July 2026, 52,607 Malaysians had lost their jobs, about 270 a day. Half were professionals, managers, executives or technicians; in 1998 and 2009 production workers were hit hardest. This time, it's the office. The minister says AI isn't a main cause yet, but ISIS Malaysia found the most AI-exposed jobs see 69% more job losses than average. 56% of Malaysian professionals use AI at work; only 26% have been trained.</a:t>
             </a:r>
           </a:p>
         </p:txBody>
@@ -863,7 +721,7 @@
           <a:lstStyle/>
           <a:p>
             <a:r>
-              <a:t>Aina is a sample persona. We invented her for this pitch. She is a front-end developer in Kuala Lumpur. Her employer pays the HRD Corp levy. The company rolls out AI coding tools. Her manager asks what training to fund this year. She needs a plan she can show him. The engine covers 923 jobs. Our first group is software and digital workers.</a:t>
+              <a:t>Kotak is for developers, testers and designers at levy-paying employers, the week AI tools arrive. Aina is a sample persona; her manager asks which training to fund.</a:t>
             </a:r>
           </a:p>
         </p:txBody>
@@ -933,7 +791,7 @@
           <a:lstStyle/>
           <a:p>
             <a:r>
-              <a:t>Aina leaves with a dated plan. On screen is the plan for her job, Web Developers, with the demo answers. At ten hours a week it starts on 2 November 2026 and reaches 80 percent fit by week 35, on 4 July 2027. The Rising skill comes first: Technical documentation, then Web testing and updates. About 320 hours of the full path remain after week 35. Each step links a free web search, labelled as a suggestion Kotak has not checked. The funding card tells a levy-paying employer to apply before training and claim only approved costs.</a:t>
+              <a:t>A course list can't answer that. Kotak can, in a three-minute check-up: 12 questions, no CV. She leaves with a dated plan: which skill first, the hours each week, a free step for each skill, and her employer's funding route. Her manager sees the dated evidence behind every step.</a:t>
             </a:r>
           </a:p>
         </p:txBody>
@@ -1003,7 +861,7 @@
           <a:lstStyle/>
           <a:p>
             <a:r>
-              <a:t>Dated snapshots feed fixed rules. The browser sets verdicts, scores and plan order. RunPod drafts skills and questions offline. Claude explains the cited rows. Kopi reads its lines aloud. Text and mute stay available. AI never sets a verdict. If it fails, a fixed template answers. Split and Unknown are valid results.</a:t>
+              <a:t>Data decides, AI explains. Answer 12 questions; fixed rules compare them with dated public data; you get a radar, ranked roles and a plan. AI never sets a verdict.</a:t>
             </a:r>
           </a:p>
         </p:txBody>
@@ -1073,7 +931,7 @@
           <a:lstStyle/>
           <a:p>
             <a:r>
-              <a:t>This is the live demo, on the real snapshots. Keep the same profile and the same 12 answers: Web Developers, level 1 on every skill. In April, Kotak has one month of AI-use data, too few points for a trend, so every skill reads Unknown. Change April to May. Technical documentation and Web specifications and standards turn Rising. Web site building turns Declining. The other three turn Steady. Web site building moves from roadmap step 4 to step 6, the last. Only the snapshot changed.</a:t>
+              <a:t>Courses are the supply; Kotak sets the priority. Of the tools we reviewed, only Kotak has a dated AI trend per skill, visible fixed maths, a timed plan to a fit target, a funding route, and an MCP server: the tool a chatbot calls.</a:t>
             </a:r>
           </a:p>
         </p:txBody>
@@ -1143,7 +1001,7 @@
           <a:lstStyle/>
           <a:p>
             <a:r>
-              <a:t>These are screens from the prototype. The check-up starts with who the worker is: their situation, study, job and goal. Then the radar, roles and roadmap form the loop. Each role says why it is there, and the highlighted one says why Kopi picked it. Connect Your AI gives any assistant the same read-only tools over MCP. The app has phone and desktop layouts, and every verdict cites its dated sources.</a:t>
+              <a:t>From at risk to ready, with receipts. 697,000 jobs are significantly affected within 3 to 5 years without upskilling; the SDG 4.4.1 baseline is 39.8%; RM2.5 billion of levy was collected for training in 2025.</a:t>
             </a:r>
           </a:p>
         </p:txBody>
@@ -1213,7 +1071,7 @@
           <a:lstStyle/>
           <a:p>
             <a:r>
-              <a:t>MyMahir maps roles and skills. LinkedIn compares skills across roles. MasterClass offers expert video courses by subscription. ReSkills is a Malaysian subscription platform for live online classes. Its provider claim is attributed to NST in 2021. e-LATiH offers free and premium courses. They offer courses. Kotak tells you which skill to learn first and why now, then points you to them. The dated rules and timed plan are our contribution.</a:t>
+              <a:t>Workers use Kotak free. Employers pay for a team view: RM5 per worker a month. For a developer on the median advertised pay the levy is RM63 a month, so Kotak costs under a tenth of it. Agencies license anonymous national totals. Prices to test, not contracts; the team view is our next build.</a:t>
             </a:r>
           </a:p>
         </p:txBody>
@@ -1283,7 +1141,7 @@
           <a:lstStyle/>
           <a:p>
             <a:r>
-              <a:t>SDG target 4.4 concerns skills for work. DOSM provides the Malaysia baseline through the UN SDG API. Our target is a sourced roadmap in under three minutes, with no uncited recommendations. The 20 seeded profiles are a Phase 2 technical test, a target and not yet a result. They are not user research or proof of job placements. One check is met now: the build fails unless all three demo roles flip a verdict from April to May. We measure whether a worker gets a dated plan they can start.</a:t>
+              <a:t>Two halves, one rulebook, no guessing. The data half builds dated snapshots; the product half runs the same rules in the browser and over MCP. AI only explains, and a check rejects any explanation that changes a verdict.</a:t>
             </a:r>
           </a:p>
         </p:txBody>
@@ -4334,90 +4192,6 @@
       <p:pic>
         <p:nvPicPr>
           <p:cNvPr id="2" name="Picture 1" descr="S10.png"/>
-          <p:cNvPicPr>
-            <a:picLocks noChangeAspect="1"/>
-          </p:cNvPicPr>
-          <p:nvPr/>
-        </p:nvPicPr>
-        <p:blipFill>
-          <a:blip r:embed="rId2"/>
-          <a:stretch>
-            <a:fillRect/>
-          </a:stretch>
-        </p:blipFill>
-        <p:spPr>
-          <a:xfrm>
-            <a:off x="0" y="0"/>
-            <a:ext cx="12192000" cy="6858000"/>
-          </a:xfrm>
-          <a:prstGeom prst="rect">
-            <a:avLst/>
-          </a:prstGeom>
-        </p:spPr>
-      </p:pic>
-    </p:spTree>
-  </p:cSld>
-  <p:clrMapOvr>
-    <a:masterClrMapping/>
-  </p:clrMapOvr>
-</p:sld>
-</file>
-
-<file path=ppt/slides/slide11.xml><?xml version="1.0" encoding="utf-8"?>
-<p:sld xmlns:a="http://schemas.openxmlformats.org/drawingml/2006/main" xmlns:p="http://schemas.openxmlformats.org/presentationml/2006/main" xmlns:r="http://schemas.openxmlformats.org/officeDocument/2006/relationships">
-  <p:cSld>
-    <p:spTree>
-      <p:nvGrpSpPr>
-        <p:cNvPr id="1" name=""/>
-        <p:cNvGrpSpPr/>
-        <p:nvPr/>
-      </p:nvGrpSpPr>
-      <p:grpSpPr/>
-      <p:pic>
-        <p:nvPicPr>
-          <p:cNvPr id="2" name="Picture 1" descr="S11.png"/>
-          <p:cNvPicPr>
-            <a:picLocks noChangeAspect="1"/>
-          </p:cNvPicPr>
-          <p:nvPr/>
-        </p:nvPicPr>
-        <p:blipFill>
-          <a:blip r:embed="rId2"/>
-          <a:stretch>
-            <a:fillRect/>
-          </a:stretch>
-        </p:blipFill>
-        <p:spPr>
-          <a:xfrm>
-            <a:off x="0" y="0"/>
-            <a:ext cx="12192000" cy="6858000"/>
-          </a:xfrm>
-          <a:prstGeom prst="rect">
-            <a:avLst/>
-          </a:prstGeom>
-        </p:spPr>
-      </p:pic>
-    </p:spTree>
-  </p:cSld>
-  <p:clrMapOvr>
-    <a:masterClrMapping/>
-  </p:clrMapOvr>
-</p:sld>
-</file>
-
-<file path=ppt/slides/slide12.xml><?xml version="1.0" encoding="utf-8"?>
-<p:sld xmlns:a="http://schemas.openxmlformats.org/drawingml/2006/main" xmlns:p="http://schemas.openxmlformats.org/presentationml/2006/main" xmlns:r="http://schemas.openxmlformats.org/officeDocument/2006/relationships">
-  <p:cSld>
-    <p:spTree>
-      <p:nvGrpSpPr>
-        <p:cNvPr id="1" name=""/>
-        <p:cNvGrpSpPr/>
-        <p:nvPr/>
-      </p:nvGrpSpPr>
-      <p:grpSpPr/>
-      <p:pic>
-        <p:nvPicPr>
-          <p:cNvPr id="2" name="Picture 1" descr="S12.png"/>
           <p:cNvPicPr>
             <a:picLocks noChangeAspect="1"/>
           </p:cNvPicPr>

</xml_diff>

<commit_message>
docs: rework the pitch deck layout
Renames pitch-deck.html to kotak-pitch-deck.html. Adds team portraits, organiser and SDG logos, plain Title Case labels, a domain-to-feature solution slide, a worker-centred impact slide, an Archify business-model diagram, and a tech diagram with real tool icons and the job-ad pipeline. Fixes the title, phone and table overlaps.

Claude-Session: https://claude.ai/code/session_01BWsADUbB5qxgQmhDHW5h1W
</commit_message>
<xml_diff>
--- a/docs/demo/deck/kotak-pitch-deck.pptx
+++ b/docs/demo/deck/kotak-pitch-deck.pptx
@@ -721,7 +721,7 @@
           <a:lstStyle/>
           <a:p>
             <a:r>
-              <a:t>Kotak is for developers, testers and designers at levy-paying employers, the week AI tools arrive. Aina is a sample persona; her manager asks which training to fund.</a:t>
+              <a:t>Kotak is for working adults in AI-exposed digital jobs: developers, QA testers and UI/UX designers, the week AI tools arrive at work. HR and L&amp;D managers at HRD Corp levy-paying employers pay. Aina is a sample persona; her manager asks which training to fund.</a:t>
             </a:r>
           </a:p>
         </p:txBody>
@@ -791,7 +791,7 @@
           <a:lstStyle/>
           <a:p>
             <a:r>
-              <a:t>A course list can't answer that. Kotak can, in a three-minute check-up: 12 questions, no CV. She leaves with a dated plan: which skill first, the hours each week, a free step for each skill, and her employer's funding route. Her manager sees the dated evidence behind every step.</a:t>
+              <a:t>Domain 1 asks for six must-haves, and Kotak delivers each: a 12-question intake, a dated AI-trend layer, ranked roles with a fit score and gap, a dated plan to 80% fit with the funding route, SDG tags on every role and step, and slow and fast AI-uptake targets labelled as estimates. Beyond the brief: What Changed, Ask Kopi and MCP.</a:t>
             </a:r>
           </a:p>
         </p:txBody>
@@ -1001,7 +1001,7 @@
           <a:lstStyle/>
           <a:p>
             <a:r>
-              <a:t>From at risk to ready, with receipts. 697,000 jobs are significantly affected within 3 to 5 years without upskilling; the SDG 4.4.1 baseline is 39.8%; RM2.5 billion of levy was collected for training in 2025.</a:t>
+              <a:t>What a worker walks away with: ranked roles and a dated plan in 3 minutes; for Aina, 80% fit by week 35 at 10 hours a week; 923 jobs covered; free for workers. Our mission: every Malaysian worker knows what AI changes in their job, and what to learn next.</a:t>
             </a:r>
           </a:p>
         </p:txBody>

</xml_diff>

<commit_message>
docs: rework the pitch deck layout (#10)
Renames pitch-deck.html to kotak-pitch-deck.html. Adds team portraits, organiser and SDG logos, plain Title Case labels, a domain-to-feature solution slide, a worker-centred impact slide, an Archify business-model diagram, and a tech diagram with real tool icons and the job-ad pipeline. Fixes the title, phone and table overlaps.

Claude-Session: https://claude.ai/code/session_01BWsADUbB5qxgQmhDHW5h1W
</commit_message>
<xml_diff>
--- a/docs/demo/deck/kotak-pitch-deck.pptx
+++ b/docs/demo/deck/kotak-pitch-deck.pptx
@@ -721,7 +721,7 @@
           <a:lstStyle/>
           <a:p>
             <a:r>
-              <a:t>Kotak is for developers, testers and designers at levy-paying employers, the week AI tools arrive. Aina is a sample persona; her manager asks which training to fund.</a:t>
+              <a:t>Kotak is for working adults in AI-exposed digital jobs: developers, QA testers and UI/UX designers, the week AI tools arrive at work. HR and L&amp;D managers at HRD Corp levy-paying employers pay. Aina is a sample persona; her manager asks which training to fund.</a:t>
             </a:r>
           </a:p>
         </p:txBody>
@@ -791,7 +791,7 @@
           <a:lstStyle/>
           <a:p>
             <a:r>
-              <a:t>A course list can't answer that. Kotak can, in a three-minute check-up: 12 questions, no CV. She leaves with a dated plan: which skill first, the hours each week, a free step for each skill, and her employer's funding route. Her manager sees the dated evidence behind every step.</a:t>
+              <a:t>Domain 1 asks for six must-haves, and Kotak delivers each: a 12-question intake, a dated AI-trend layer, ranked roles with a fit score and gap, a dated plan to 80% fit with the funding route, SDG tags on every role and step, and slow and fast AI-uptake targets labelled as estimates. Beyond the brief: What Changed, Ask Kopi and MCP.</a:t>
             </a:r>
           </a:p>
         </p:txBody>
@@ -1001,7 +1001,7 @@
           <a:lstStyle/>
           <a:p>
             <a:r>
-              <a:t>From at risk to ready, with receipts. 697,000 jobs are significantly affected within 3 to 5 years without upskilling; the SDG 4.4.1 baseline is 39.8%; RM2.5 billion of levy was collected for training in 2025.</a:t>
+              <a:t>What a worker walks away with: ranked roles and a dated plan in 3 minutes; for Aina, 80% fit by week 35 at 10 hours a week; 923 jobs covered; free for workers. Our mission: every Malaysian worker knows what AI changes in their job, and what to learn next.</a:t>
             </a:r>
           </a:p>
         </p:txBody>

</xml_diff>

<commit_message>
docs: sync the script with deck v3
The narration follows the reworked slides: V4 says Kotak covers all six Domain 1 must-haves, V7 speaks the worker's gain instead of the national figures, and V9 adds the daily job-ad pipeline. Speaker notes 4, 7 and 9 match. Runtime 6:29.

Claude-Session: https://claude.ai/code/session_01BWsADUbB5qxgQmhDHW5h1W
</commit_message>
<xml_diff>
--- a/docs/demo/deck/kotak-pitch-deck.pptx
+++ b/docs/demo/deck/kotak-pitch-deck.pptx
@@ -791,7 +791,7 @@
           <a:lstStyle/>
           <a:p>
             <a:r>
-              <a:t>Domain 1 asks for six must-haves, and Kotak delivers each: a 12-question intake, a dated AI-trend layer, ranked roles with a fit score and gap, a dated plan to 80% fit with the funding route, SDG tags on every role and step, and slow and fast AI-uptake targets labelled as estimates. Beyond the brief: What Changed, Ask Kopi and MCP.</a:t>
+              <a:t>A course list can't answer that. Kotak can, in a three-minute check-up: 12 questions, no CV. She leaves with a dated plan: which skill first, the hours each week, a free step for each skill, and her employer's funding route. And it covers all six must-haves in the Domain 1 brief, from a dated trend layer to SDG tags.</a:t>
             </a:r>
           </a:p>
         </p:txBody>
@@ -1001,7 +1001,7 @@
           <a:lstStyle/>
           <a:p>
             <a:r>
-              <a:t>What a worker walks away with: ranked roles and a dated plan in 3 minutes; for Aina, 80% fit by week 35 at 10 hours a week; 923 jobs covered; free for workers. Our mission: every Malaysian worker knows what AI changes in their job, and what to learn next.</a:t>
+              <a:t>For a worker, the gain is plain: three minutes, a plan to 80% fit, and nothing to pay, across 923 jobs. For Malaysia, the levy already funds training; Kotak helps aim it at the rising skills. That's SDG 4.4: skills for decent work.</a:t>
             </a:r>
           </a:p>
         </p:txBody>
@@ -1141,7 +1141,7 @@
           <a:lstStyle/>
           <a:p>
             <a:r>
-              <a:t>Two halves, one rulebook, no guessing. The data half builds dated snapshots; the product half runs the same rules in the browser and over MCP. AI only explains, and a check rejects any explanation that changes a verdict.</a:t>
+              <a:t>Two halves share one rulebook. Every week, dated public data becomes a snapshot; every day, new JobStreet ads come in, Claude sorts them and a person checks them. RunPod drafted skills and questions for 923 jobs in 13 minutes. In the app, the rules run in your browser. Claude Haiku explains, and a check rejects any explanation that changes a verdict. Live on Replit; over 120 automated tests pass on every change.</a:t>
             </a:r>
           </a:p>
         </p:txBody>

</xml_diff>

<commit_message>
docs: sync the script with deck v3 (#11)
The narration follows the reworked slides: V4 says Kotak covers all six Domain 1 must-haves, V7 speaks the worker's gain instead of the national figures, and V9 adds the daily job-ad pipeline. Speaker notes 4, 7 and 9 match. Runtime 6:29.

Claude-Session: https://claude.ai/code/session_01BWsADUbB5qxgQmhDHW5h1W
</commit_message>
<xml_diff>
--- a/docs/demo/deck/kotak-pitch-deck.pptx
+++ b/docs/demo/deck/kotak-pitch-deck.pptx
@@ -791,7 +791,7 @@
           <a:lstStyle/>
           <a:p>
             <a:r>
-              <a:t>Domain 1 asks for six must-haves, and Kotak delivers each: a 12-question intake, a dated AI-trend layer, ranked roles with a fit score and gap, a dated plan to 80% fit with the funding route, SDG tags on every role and step, and slow and fast AI-uptake targets labelled as estimates. Beyond the brief: What Changed, Ask Kopi and MCP.</a:t>
+              <a:t>A course list can't answer that. Kotak can, in a three-minute check-up: 12 questions, no CV. She leaves with a dated plan: which skill first, the hours each week, a free step for each skill, and her employer's funding route. And it covers all six must-haves in the Domain 1 brief, from a dated trend layer to SDG tags.</a:t>
             </a:r>
           </a:p>
         </p:txBody>
@@ -1001,7 +1001,7 @@
           <a:lstStyle/>
           <a:p>
             <a:r>
-              <a:t>What a worker walks away with: ranked roles and a dated plan in 3 minutes; for Aina, 80% fit by week 35 at 10 hours a week; 923 jobs covered; free for workers. Our mission: every Malaysian worker knows what AI changes in their job, and what to learn next.</a:t>
+              <a:t>For a worker, the gain is plain: three minutes, a plan to 80% fit, and nothing to pay, across 923 jobs. For Malaysia, the levy already funds training; Kotak helps aim it at the rising skills. That's SDG 4.4: skills for decent work.</a:t>
             </a:r>
           </a:p>
         </p:txBody>
@@ -1141,7 +1141,7 @@
           <a:lstStyle/>
           <a:p>
             <a:r>
-              <a:t>Two halves, one rulebook, no guessing. The data half builds dated snapshots; the product half runs the same rules in the browser and over MCP. AI only explains, and a check rejects any explanation that changes a verdict.</a:t>
+              <a:t>Two halves share one rulebook. Every week, dated public data becomes a snapshot; every day, new JobStreet ads come in, Claude sorts them and a person checks them. RunPod drafted skills and questions for 923 jobs in 13 minutes. In the app, the rules run in your browser. Claude Haiku explains, and a check rejects any explanation that changes a verdict. Live on Replit; over 120 automated tests pass on every change.</a:t>
             </a:r>
           </a:p>
         </p:txBody>

</xml_diff>

<commit_message>
docs: tighten the script and slide 6
Keeps the team's own script edits. V3 says Aina works at a tech company that just rolled out AI coding tools, matching the deck. V4 says what the dated plan is: a week-by-week reskilling calendar to 80% fit. V6 and slide 6 replace 'Courses are the supply' with plain words. Speaker notes 3, 4 and 6 match.

Claude-Session: https://claude.ai/code/session_01BWsADUbB5qxgQmhDHW5h1W
</commit_message>
<xml_diff>
--- a/docs/demo/deck/kotak-pitch-deck.pptx
+++ b/docs/demo/deck/kotak-pitch-deck.pptx
@@ -721,7 +721,7 @@
           <a:lstStyle/>
           <a:p>
             <a:r>
-              <a:t>Kotak is for working adults in AI-exposed digital jobs: developers, QA testers and UI/UX designers, the week AI tools arrive at work. HR and L&amp;D managers at HRD Corp levy-paying employers pay. Aina is a sample persona; her manager asks which training to fund.</a:t>
+              <a:t>Kotak is for working adults in AI-exposed digital jobs: developers, QA testers and UI/UX designers, the week tech companies roll out AI coding tools. HR and L&amp;D managers at HRD Corp levy-paying employers pay. Aina is a sample persona at a tech company; her manager asks which training to fund.</a:t>
             </a:r>
           </a:p>
         </p:txBody>
@@ -791,7 +791,7 @@
           <a:lstStyle/>
           <a:p>
             <a:r>
-              <a:t>A course list can't answer that. Kotak can, in a three-minute check-up: 12 questions, no CV. She leaves with a dated plan: which skill first, the hours each week, a free step for each skill, and her employer's funding route. And it covers all six must-haves in the Domain 1 brief, from a dated trend layer to SDG tags.</a:t>
+              <a:t>A course list can't answer that. Kotak can, in a three-minute check-up: 12 questions, no CV. She leaves with a dated plan: a week-by-week reskilling calendar, from her start date to 80% fit for her job, with which skill first, the hours each week, a free step for each skill, and her employer's funding route. And it covers all six must-haves in the Domain 1 brief.</a:t>
             </a:r>
           </a:p>
         </p:txBody>
@@ -931,7 +931,7 @@
           <a:lstStyle/>
           <a:p>
             <a:r>
-              <a:t>Courses are the supply; Kotak sets the priority. Of the tools we reviewed, only Kotak has a dated AI trend per skill, visible fixed maths, a timed plan to a fit target, a funding route, and an MCP server: the tool a chatbot calls.</a:t>
+              <a:t>MyMahir and LinkedIn map skills; MasterClass, ReSkills and e-LATiH offer courses; a chatbot can't say where its plan came from. Kotak is the only one we found that dates each skill's AI trend, shows its maths, times the plan, points to funding, and lets any AI call the same rules. Course sites tell you what you could learn. Kotak tells you what to learn first, and why.</a:t>
             </a:r>
           </a:p>
         </p:txBody>

</xml_diff>

<commit_message>
docs: tighten the script and slide 6 (#13)
Keeps the team's own script edits. V3 says Aina works at a tech company that just rolled out AI coding tools, matching the deck. V4 says what the dated plan is: a week-by-week reskilling calendar to 80% fit. V6 and slide 6 replace 'Courses are the supply' with plain words. Speaker notes 3, 4 and 6 match.

Claude-Session: https://claude.ai/code/session_01BWsADUbB5qxgQmhDHW5h1W
</commit_message>
<xml_diff>
--- a/docs/demo/deck/kotak-pitch-deck.pptx
+++ b/docs/demo/deck/kotak-pitch-deck.pptx
@@ -721,7 +721,7 @@
           <a:lstStyle/>
           <a:p>
             <a:r>
-              <a:t>Kotak is for working adults in AI-exposed digital jobs: developers, QA testers and UI/UX designers, the week AI tools arrive at work. HR and L&amp;D managers at HRD Corp levy-paying employers pay. Aina is a sample persona; her manager asks which training to fund.</a:t>
+              <a:t>Kotak is for working adults in AI-exposed digital jobs: developers, QA testers and UI/UX designers, the week tech companies roll out AI coding tools. HR and L&amp;D managers at HRD Corp levy-paying employers pay. Aina is a sample persona at a tech company; her manager asks which training to fund.</a:t>
             </a:r>
           </a:p>
         </p:txBody>
@@ -791,7 +791,7 @@
           <a:lstStyle/>
           <a:p>
             <a:r>
-              <a:t>A course list can't answer that. Kotak can, in a three-minute check-up: 12 questions, no CV. She leaves with a dated plan: which skill first, the hours each week, a free step for each skill, and her employer's funding route. And it covers all six must-haves in the Domain 1 brief, from a dated trend layer to SDG tags.</a:t>
+              <a:t>A course list can't answer that. Kotak can, in a three-minute check-up: 12 questions, no CV. She leaves with a dated plan: a week-by-week reskilling calendar, from her start date to 80% fit for her job, with which skill first, the hours each week, a free step for each skill, and her employer's funding route. And it covers all six must-haves in the Domain 1 brief.</a:t>
             </a:r>
           </a:p>
         </p:txBody>
@@ -931,7 +931,7 @@
           <a:lstStyle/>
           <a:p>
             <a:r>
-              <a:t>Courses are the supply; Kotak sets the priority. Of the tools we reviewed, only Kotak has a dated AI trend per skill, visible fixed maths, a timed plan to a fit target, a funding route, and an MCP server: the tool a chatbot calls.</a:t>
+              <a:t>MyMahir and LinkedIn map skills; MasterClass, ReSkills and e-LATiH offer courses; a chatbot can't say where its plan came from. Kotak is the only one we found that dates each skill's AI trend, shows its maths, times the plan, points to funding, and lets any AI call the same rules. Course sites tell you what you could learn. Kotak tells you what to learn first, and why.</a:t>
             </a:r>
           </a:p>
         </p:txBody>

</xml_diff>